<commit_message>
Add per-SKU PPT: 2026-08-24_B0501001_S_AHH90013.pptx
</commit_message>
<xml_diff>
--- a/ppt/2026-08-24_B0501001_S_AHH90013.pptx
+++ b/ppt/2026-08-24_B0501001_S_AHH90013.pptx
@@ -1156,7 +1156,7 @@
                 <a:ea typeface="Arial Black" pitchFamily="34" charset="-122"/>
                 <a:cs typeface="Arial Black" pitchFamily="34" charset="-120"/>
               </a:rPr>
-              <a:t>9</a:t>
+              <a:t>6</a:t>
             </a:r>
             <a:endParaRPr lang="en-US" sz="4000" dirty="0"/>
           </a:p>
@@ -1195,7 +1195,7 @@
                 <a:ea typeface="Microsoft JhengHei" pitchFamily="34" charset="-122"/>
                 <a:cs typeface="Microsoft JhengHei" pitchFamily="34" charset="-120"/>
               </a:rPr>
-              <a:t>[平行進口]Synbiotic D-C 益生菌(貓狗用) 50粒</a:t>
+              <a:t>[平行進口]Synbiotic D-C 益生菌(貓狗用) 50粒 (新舊包裝隨機發貨)</a:t>
             </a:r>
             <a:endParaRPr lang="en-US" sz="2500" dirty="0"/>
           </a:p>
@@ -1533,7 +1533,7 @@
                 <a:ea typeface="Arial Black" pitchFamily="34" charset="-122"/>
                 <a:cs typeface="Arial Black" pitchFamily="34" charset="-120"/>
               </a:rPr>
-              <a:t>$31,208</a:t>
+              <a:t>$31,207.85</a:t>
             </a:r>
             <a:endParaRPr lang="en-US" sz="1600" dirty="0"/>
           </a:p>
@@ -1855,7 +1855,7 @@
                 <a:ea typeface="Microsoft JhengHei" pitchFamily="34" charset="-122"/>
                 <a:cs typeface="Microsoft JhengHei" pitchFamily="34" charset="-120"/>
               </a:rPr>
-              <a:t>📢 益生菌迷思影片 11 日前（類別話題）；開箱測試 10 個月前 — 類別討論但非直接產品</a:t>
+              <a:t>📢 益生菌迷思影片 11日前（通用話題非此產品）；開箱 260 億機能益生菌 — 類別討論但非直接產品</a:t>
             </a:r>
             <a:endParaRPr lang="en-US" sz="950" dirty="0"/>
           </a:p>
@@ -1903,7 +1903,7 @@
                   </a:extLst>
                 </a:hlinkClick>
               </a:rPr>
-              <a:t>📺 https://www.youtube.com/watch?v=1q6Cdl3aIeI</a:t>
+              <a:t>📺 https://www.youtube.com/watch?v=zEfiywrtApc</a:t>
             </a:r>
             <a:endParaRPr lang="en-US" sz="900" dirty="0"/>
           </a:p>

</xml_diff>